<commit_message>
docs(presentation): update final member names
</commit_message>
<xml_diff>
--- a/presentation/presentation.pptx
+++ b/presentation/presentation.pptx
@@ -2,23 +2,23 @@
 <file path=ppt/presentation.xml><?xml version="1.0" encoding="utf-8"?>
 <p:presentation xmlns:p="http://schemas.openxmlformats.org/presentationml/2006/main">
   <p:sldMasterIdLst>
-    <p:sldMasterId xmlns:r="http://schemas.openxmlformats.org/officeDocument/2006/relationships" id="2147483648" r:id="R47d47c3a1360401f"/>
+    <p:sldMasterId xmlns:r="http://schemas.openxmlformats.org/officeDocument/2006/relationships" id="2147483648" r:id="R265a4da636084d94"/>
   </p:sldMasterIdLst>
   <p:notesMasterIdLst>
-    <p:notesMasterId xmlns:r="http://schemas.openxmlformats.org/officeDocument/2006/relationships" r:id="Rf7b3928d0fa14a19"/>
+    <p:notesMasterId xmlns:r="http://schemas.openxmlformats.org/officeDocument/2006/relationships" r:id="R08564871a5804ad3"/>
   </p:notesMasterIdLst>
   <p:sldIdLst>
-    <p:sldId xmlns:r="http://schemas.openxmlformats.org/officeDocument/2006/relationships" id="256" r:id="R52da7c753ffa4f9c"/>
-    <p:sldId xmlns:r="http://schemas.openxmlformats.org/officeDocument/2006/relationships" id="257" r:id="R5eac1a37f1cf44ef"/>
-    <p:sldId xmlns:r="http://schemas.openxmlformats.org/officeDocument/2006/relationships" id="258" r:id="R1796249dcbbb45ca"/>
-    <p:sldId xmlns:r="http://schemas.openxmlformats.org/officeDocument/2006/relationships" id="259" r:id="R65115494cb694059"/>
-    <p:sldId xmlns:r="http://schemas.openxmlformats.org/officeDocument/2006/relationships" id="260" r:id="R4732a0e057994d1f"/>
-    <p:sldId xmlns:r="http://schemas.openxmlformats.org/officeDocument/2006/relationships" id="261" r:id="Rbdce5f11342c4c6b"/>
-    <p:sldId xmlns:r="http://schemas.openxmlformats.org/officeDocument/2006/relationships" id="262" r:id="R62e3d4493cc74a4c"/>
-    <p:sldId xmlns:r="http://schemas.openxmlformats.org/officeDocument/2006/relationships" id="263" r:id="Rc8c25178ce7f4b2b"/>
-    <p:sldId xmlns:r="http://schemas.openxmlformats.org/officeDocument/2006/relationships" id="264" r:id="Rbec1bfd2e0144b65"/>
-    <p:sldId xmlns:r="http://schemas.openxmlformats.org/officeDocument/2006/relationships" id="265" r:id="Rf985234803e24f8c"/>
-    <p:sldId xmlns:r="http://schemas.openxmlformats.org/officeDocument/2006/relationships" id="266" r:id="R0196e5b45d0f4082"/>
+    <p:sldId xmlns:r="http://schemas.openxmlformats.org/officeDocument/2006/relationships" id="256" r:id="Rdc03de7b40d64032"/>
+    <p:sldId xmlns:r="http://schemas.openxmlformats.org/officeDocument/2006/relationships" id="257" r:id="R3cccdf5461d741d9"/>
+    <p:sldId xmlns:r="http://schemas.openxmlformats.org/officeDocument/2006/relationships" id="258" r:id="R9fa148f881144e71"/>
+    <p:sldId xmlns:r="http://schemas.openxmlformats.org/officeDocument/2006/relationships" id="259" r:id="R2b6ec855e3574d95"/>
+    <p:sldId xmlns:r="http://schemas.openxmlformats.org/officeDocument/2006/relationships" id="260" r:id="R01ff792310314201"/>
+    <p:sldId xmlns:r="http://schemas.openxmlformats.org/officeDocument/2006/relationships" id="261" r:id="R4f5b263c4f3147a5"/>
+    <p:sldId xmlns:r="http://schemas.openxmlformats.org/officeDocument/2006/relationships" id="262" r:id="R163ad06ab6bc40e8"/>
+    <p:sldId xmlns:r="http://schemas.openxmlformats.org/officeDocument/2006/relationships" id="263" r:id="R412525ac7eb84984"/>
+    <p:sldId xmlns:r="http://schemas.openxmlformats.org/officeDocument/2006/relationships" id="264" r:id="R1da15ef931e84b88"/>
+    <p:sldId xmlns:r="http://schemas.openxmlformats.org/officeDocument/2006/relationships" id="265" r:id="R540d695492d84bb8"/>
+    <p:sldId xmlns:r="http://schemas.openxmlformats.org/officeDocument/2006/relationships" id="266" r:id="R124987eabb9349bb"/>
   </p:sldIdLst>
   <p:sldSz cx="12192000" cy="6858000"/>
   <p:notesSz cx="6858000" cy="9144000"/>
@@ -1271,7 +1271,7 @@
   </p:cSld>
   <p:clrMap bg1="lt1" tx1="dk1" bg2="lt2" tx2="dk2" accent1="accent1" accent2="accent2" accent3="accent3" accent4="accent4" accent5="accent5" accent6="accent6" hlink="hlink" folHlink="folHlink"/>
   <p:sldLayoutIdLst>
-    <p:sldLayoutId xmlns:r="http://schemas.openxmlformats.org/officeDocument/2006/relationships" id="2147483649" r:id="Rfdfdcf4b79c9488b"/>
+    <p:sldLayoutId xmlns:r="http://schemas.openxmlformats.org/officeDocument/2006/relationships" id="2147483649" r:id="R55c38b2dc1e04ee5"/>
   </p:sldLayoutIdLst>
   <p:txStyles>
     <p:titleStyle>
@@ -1980,7 +1980,7 @@
         </p:spPr>
         <p:txBody>
           <a:bodyPr xmlns:a="http://schemas.openxmlformats.org/drawingml/2006/main" lIns="0" tIns="0" rIns="0" bIns="0" anchor="t">
-            <a:normAutofit fontScale="100000"/>
+            <a:normAutofit fontScale="91714"/>
           </a:bodyPr>
           <a:lstStyle xmlns:a="http://schemas.openxmlformats.org/drawingml/2006/main"/>
           <a:p xmlns:a="http://schemas.openxmlformats.org/drawingml/2006/main">
@@ -1996,7 +1996,7 @@
               </a:defRPr>
             </a:pPr>
             <a:r>
-              <a:t>Member A  |  Member B  |  Member C  |  Member D</a:t>
+              <a:t>Milana Karimova  |  Sharaf Feyzullayev  |  Nijat Agayev  |  Farah Feyzullayev</a:t>
             </a:r>
           </a:p>
         </p:txBody>
@@ -2084,7 +2084,7 @@
       </p:sp>
       <p:cxnSp>
         <p:nvCxnSpPr>
-          <p:cNvPr id="33" name="rule-7"/>
+          <p:cNvPr id="49" name="rule-7"/>
           <p:cNvCxnSpPr/>
           <p:nvPr/>
         </p:nvCxnSpPr>
@@ -2198,14 +2198,14 @@
       </p:sp>
       <p:pic>
         <p:nvPicPr>
-          <p:cNvPr id="36" name=""/>
+          <p:cNvPr id="52" name=""/>
           <p:cNvPicPr>
             <a:picLocks xmlns:a="http://schemas.openxmlformats.org/drawingml/2006/main" noChangeAspect="1"/>
           </p:cNvPicPr>
           <p:nvPr/>
         </p:nvPicPr>
         <p:blipFill>
-          <a:blip xmlns:r="http://schemas.openxmlformats.org/officeDocument/2006/relationships" xmlns:a="http://schemas.openxmlformats.org/drawingml/2006/main" r:embed="Rfbf670a5e9244dd9"/>
+          <a:blip xmlns:r="http://schemas.openxmlformats.org/officeDocument/2006/relationships" xmlns:a="http://schemas.openxmlformats.org/drawingml/2006/main" r:embed="Rdbdea98c50764131"/>
           <a:srcRect xmlns:a="http://schemas.openxmlformats.org/drawingml/2006/main" l="0" t="0" r="0" b="0"/>
           <a:stretch xmlns:a="http://schemas.openxmlformats.org/drawingml/2006/main"/>
         </p:blipFill>
@@ -2459,7 +2459,7 @@
       </p:sp>
       <p:cxnSp>
         <p:nvCxnSpPr>
-          <p:cNvPr id="42" name="rule-117"/>
+          <p:cNvPr id="62" name="rule-117"/>
           <p:cNvCxnSpPr/>
           <p:nvPr/>
         </p:nvCxnSpPr>
@@ -2573,7 +2573,7 @@
       </p:sp>
       <p:cxnSp>
         <p:nvCxnSpPr>
-          <p:cNvPr id="45" name="rule-120"/>
+          <p:cNvPr id="65" name="rule-120"/>
           <p:cNvCxnSpPr/>
           <p:nvPr/>
         </p:nvCxnSpPr>
@@ -2871,14 +2871,14 @@
       </p:sp>
       <p:pic>
         <p:nvPicPr>
-          <p:cNvPr id="52" name=""/>
+          <p:cNvPr id="72" name=""/>
           <p:cNvPicPr>
             <a:picLocks xmlns:a="http://schemas.openxmlformats.org/drawingml/2006/main" noChangeAspect="1"/>
           </p:cNvPicPr>
           <p:nvPr/>
         </p:nvPicPr>
         <p:blipFill>
-          <a:blip xmlns:r="http://schemas.openxmlformats.org/officeDocument/2006/relationships" xmlns:a="http://schemas.openxmlformats.org/drawingml/2006/main" r:embed="Rd79d1cd766f54076"/>
+          <a:blip xmlns:r="http://schemas.openxmlformats.org/officeDocument/2006/relationships" xmlns:a="http://schemas.openxmlformats.org/drawingml/2006/main" r:embed="Re0e46bba3f2a422d"/>
           <a:srcRect xmlns:a="http://schemas.openxmlformats.org/drawingml/2006/main" l="0" t="0" r="0" b="0"/>
           <a:stretch xmlns:a="http://schemas.openxmlformats.org/drawingml/2006/main"/>
         </p:blipFill>
@@ -3015,7 +3015,7 @@
       </p:sp>
       <p:cxnSp>
         <p:nvCxnSpPr>
-          <p:cNvPr id="20" name="rule-130"/>
+          <p:cNvPr id="26" name="rule-130"/>
           <p:cNvCxnSpPr/>
           <p:nvPr/>
         </p:nvCxnSpPr>
@@ -4903,7 +4903,7 @@
       </p:sp>
       <p:cxnSp>
         <p:nvCxnSpPr>
-          <p:cNvPr id="38" name="rule-41"/>
+          <p:cNvPr id="56" name="rule-41"/>
           <p:cNvCxnSpPr/>
           <p:nvPr/>
         </p:nvCxnSpPr>
@@ -5017,7 +5017,7 @@
       </p:sp>
       <p:cxnSp>
         <p:nvCxnSpPr>
-          <p:cNvPr id="41" name="rule-44"/>
+          <p:cNvPr id="59" name="rule-44"/>
           <p:cNvCxnSpPr/>
           <p:nvPr/>
         </p:nvCxnSpPr>
@@ -5131,7 +5131,7 @@
       </p:sp>
       <p:cxnSp>
         <p:nvCxnSpPr>
-          <p:cNvPr id="44" name="rule-47"/>
+          <p:cNvPr id="62" name="rule-47"/>
           <p:cNvCxnSpPr/>
           <p:nvPr/>
         </p:nvCxnSpPr>
@@ -5896,7 +5896,7 @@
       </p:sp>
       <p:cxnSp>
         <p:nvCxnSpPr>
-          <p:cNvPr id="43" name="rule-64"/>
+          <p:cNvPr id="61" name="rule-64"/>
           <p:cNvCxnSpPr/>
           <p:nvPr/>
         </p:nvCxnSpPr>
@@ -6622,7 +6622,7 @@
           <p:nvPr/>
         </p:nvPicPr>
         <p:blipFill>
-          <a:blip xmlns:r="http://schemas.openxmlformats.org/officeDocument/2006/relationships" xmlns:a="http://schemas.openxmlformats.org/drawingml/2006/main" r:embed="R915d8331800a4c15"/>
+          <a:blip xmlns:r="http://schemas.openxmlformats.org/officeDocument/2006/relationships" xmlns:a="http://schemas.openxmlformats.org/drawingml/2006/main" r:embed="R3be726a6a2b44ebb"/>
           <a:srcRect xmlns:a="http://schemas.openxmlformats.org/drawingml/2006/main" l="0" t="0" r="0" b="0"/>
           <a:stretch xmlns:a="http://schemas.openxmlformats.org/drawingml/2006/main"/>
         </p:blipFill>
@@ -6645,7 +6645,7 @@
           <p:nvPr/>
         </p:nvPicPr>
         <p:blipFill>
-          <a:blip xmlns:r="http://schemas.openxmlformats.org/officeDocument/2006/relationships" xmlns:a="http://schemas.openxmlformats.org/drawingml/2006/main" r:embed="R8e8b02dee1104275"/>
+          <a:blip xmlns:r="http://schemas.openxmlformats.org/officeDocument/2006/relationships" xmlns:a="http://schemas.openxmlformats.org/drawingml/2006/main" r:embed="R12d5b26881794172"/>
           <a:srcRect xmlns:a="http://schemas.openxmlformats.org/drawingml/2006/main" l="0" t="0" r="0" b="0"/>
           <a:stretch xmlns:a="http://schemas.openxmlformats.org/drawingml/2006/main"/>
         </p:blipFill>
@@ -7181,7 +7181,7 @@
           <p:nvPr/>
         </p:nvPicPr>
         <p:blipFill>
-          <a:blip xmlns:r="http://schemas.openxmlformats.org/officeDocument/2006/relationships" xmlns:a="http://schemas.openxmlformats.org/drawingml/2006/main" r:embed="Re45c107379694b10"/>
+          <a:blip xmlns:r="http://schemas.openxmlformats.org/officeDocument/2006/relationships" xmlns:a="http://schemas.openxmlformats.org/drawingml/2006/main" r:embed="R3eda5f5c926e4a52"/>
           <a:srcRect xmlns:a="http://schemas.openxmlformats.org/drawingml/2006/main" l="0" t="0" r="0" b="0"/>
           <a:stretch xmlns:a="http://schemas.openxmlformats.org/drawingml/2006/main"/>
         </p:blipFill>
@@ -7579,7 +7579,7 @@
           <p:nvPr/>
         </p:nvPicPr>
         <p:blipFill>
-          <a:blip xmlns:r="http://schemas.openxmlformats.org/officeDocument/2006/relationships" xmlns:a="http://schemas.openxmlformats.org/drawingml/2006/main" r:embed="Rddd6aafb701c4acc"/>
+          <a:blip xmlns:r="http://schemas.openxmlformats.org/officeDocument/2006/relationships" xmlns:a="http://schemas.openxmlformats.org/drawingml/2006/main" r:embed="R8b12578f4f7b485f"/>
           <a:srcRect xmlns:a="http://schemas.openxmlformats.org/drawingml/2006/main" l="0" t="0" r="0" b="0"/>
           <a:stretch xmlns:a="http://schemas.openxmlformats.org/drawingml/2006/main"/>
         </p:blipFill>
@@ -7602,7 +7602,7 @@
           <p:nvPr/>
         </p:nvPicPr>
         <p:blipFill>
-          <a:blip xmlns:r="http://schemas.openxmlformats.org/officeDocument/2006/relationships" xmlns:a="http://schemas.openxmlformats.org/drawingml/2006/main" r:embed="R9b53067b778b4cfa"/>
+          <a:blip xmlns:r="http://schemas.openxmlformats.org/officeDocument/2006/relationships" xmlns:a="http://schemas.openxmlformats.org/drawingml/2006/main" r:embed="Rcb4e164306c74ab7"/>
           <a:srcRect xmlns:a="http://schemas.openxmlformats.org/drawingml/2006/main" l="0" t="0" r="0" b="0"/>
           <a:stretch xmlns:a="http://schemas.openxmlformats.org/drawingml/2006/main"/>
         </p:blipFill>
@@ -7855,7 +7855,7 @@
       </p:sp>
       <p:cxnSp>
         <p:nvCxnSpPr>
-          <p:cNvPr id="40" name="rule-104"/>
+          <p:cNvPr id="60" name="rule-104"/>
           <p:cNvCxnSpPr/>
           <p:nvPr/>
         </p:nvCxnSpPr>
@@ -7969,7 +7969,7 @@
       </p:sp>
       <p:cxnSp>
         <p:nvCxnSpPr>
-          <p:cNvPr id="43" name="rule-107"/>
+          <p:cNvPr id="63" name="rule-107"/>
           <p:cNvCxnSpPr/>
           <p:nvPr/>
         </p:nvCxnSpPr>
@@ -8175,14 +8175,14 @@
       </p:sp>
       <p:pic>
         <p:nvPicPr>
-          <p:cNvPr id="48" name=""/>
+          <p:cNvPr id="68" name=""/>
           <p:cNvPicPr>
             <a:picLocks xmlns:a="http://schemas.openxmlformats.org/drawingml/2006/main" noChangeAspect="1"/>
           </p:cNvPicPr>
           <p:nvPr/>
         </p:nvPicPr>
         <p:blipFill>
-          <a:blip xmlns:r="http://schemas.openxmlformats.org/officeDocument/2006/relationships" xmlns:a="http://schemas.openxmlformats.org/drawingml/2006/main" r:embed="Rbb89b88cf0cf43f4"/>
+          <a:blip xmlns:r="http://schemas.openxmlformats.org/officeDocument/2006/relationships" xmlns:a="http://schemas.openxmlformats.org/drawingml/2006/main" r:embed="R6395a52c64e740c1"/>
           <a:srcRect xmlns:a="http://schemas.openxmlformats.org/drawingml/2006/main" l="0" t="0" r="0" b="0"/>
           <a:stretch xmlns:a="http://schemas.openxmlformats.org/drawingml/2006/main"/>
         </p:blipFill>

</xml_diff>